<commit_message>
chore(so-lieu): 400 test · 38 mẫu · 14/14 luật có cặp
Co-Authored-By: Claude Opus 5 <noreply@anthropic.com>
</commit_message>
<xml_diff>
--- a/docs/nop-bai/CUSTOS-PITCH.pptx
+++ b/docs/nop-bai/CUSTOS-PITCH.pptx
@@ -5622,7 +5622,7 @@
                 <a:ea typeface="Trebuchet MS" pitchFamily="34" charset="-122"/>
                 <a:cs typeface="Trebuchet MS" pitchFamily="34" charset="-120"/>
               </a:rPr>
-              <a:t>395</a:t>
+              <a:t>400</a:t>
             </a:r>
             <a:endParaRPr lang="en-US" sz="4400" dirty="0"/>
           </a:p>
@@ -5856,7 +5856,7 @@
                 <a:ea typeface="Calibri" pitchFamily="34" charset="-122"/>
                 <a:cs typeface="Calibri" pitchFamily="34" charset="-120"/>
               </a:rPr>
-              <a:t>33 mẫu kiểm thử</a:t>
+              <a:t>38 mẫu kiểm thử</a:t>
             </a:r>
             <a:endParaRPr lang="en-US" sz="1100" dirty="0"/>
           </a:p>

</xml_diff>